<commit_message>
Update PowerPoint for song #88 in FUBC - Українські
</commit_message>
<xml_diff>
--- a/fubc-ua/88-Хочу, Боже, вдячним бути (Пісні Спасенних №83).pptx
+++ b/fubc-ua/88-Хочу, Боже, вдячним бути (Пісні Спасенних №83).pptx
@@ -595,7 +595,7 @@
           <a:p>
             <a:r>
               <a:rPr lang="en-US" dirty="0"/>
-              <a:t>1 · 1/1</a:t>
+              <a:t>1 · 1/1 · ||:3-4:||</a:t>
             </a:r>
             <a:endParaRPr lang="en-US" dirty="0"/>
           </a:p>
@@ -683,7 +683,7 @@
           <a:p>
             <a:r>
               <a:rPr lang="en-US" dirty="0"/>
-              <a:t>2 · 1/1</a:t>
+              <a:t>2 · 1/1 · ||:3-4:||</a:t>
             </a:r>
             <a:endParaRPr lang="en-US" dirty="0"/>
           </a:p>
@@ -771,7 +771,7 @@
           <a:p>
             <a:r>
               <a:rPr lang="en-US" dirty="0"/>
-              <a:t>3 · 1/1</a:t>
+              <a:t>3 · 1/1 · ||:3-4:||</a:t>
             </a:r>
             <a:endParaRPr lang="en-US" dirty="0"/>
           </a:p>
@@ -859,7 +859,7 @@
           <a:p>
             <a:r>
               <a:rPr lang="en-US" dirty="0"/>
-              <a:t>4 · 1/1</a:t>
+              <a:t>4 · 1/1 · ||:3-4:||</a:t>
             </a:r>
             <a:endParaRPr lang="en-US" dirty="0"/>
           </a:p>
@@ -1430,6 +1430,9 @@
           <a:lstStyle/>
           <a:p>
             <a:pPr algn="ctr" indent="0" marL="0">
+              <a:lnSpc>
+                <a:spcPts val="6200"/>
+              </a:lnSpc>
               <a:buNone/>
             </a:pPr>
             <a:r>
@@ -1447,6 +1450,9 @@
           </a:p>
           <a:p>
             <a:pPr algn="ctr" indent="0" marL="0">
+              <a:lnSpc>
+                <a:spcPts val="6200"/>
+              </a:lnSpc>
               <a:buNone/>
             </a:pPr>
             <a:r>
@@ -1464,6 +1470,9 @@
           </a:p>
           <a:p>
             <a:pPr algn="ctr" indent="0" marL="0">
+              <a:lnSpc>
+                <a:spcPts val="6200"/>
+              </a:lnSpc>
               <a:buNone/>
             </a:pPr>
             <a:r>
@@ -1475,12 +1484,15 @@
                 <a:ea typeface="Arial" pitchFamily="34" charset="-122"/>
                 <a:cs typeface="Arial" pitchFamily="34" charset="-120"/>
               </a:rPr>
-              <a:t>||: благодать Твою збагнути</a:t>
+              <a:t>благодать Твою збагнути</a:t>
             </a:r>
             <a:endParaRPr lang="en-US" sz="5200" dirty="0"/>
           </a:p>
           <a:p>
             <a:pPr algn="ctr" indent="0" marL="0">
+              <a:lnSpc>
+                <a:spcPts val="6200"/>
+              </a:lnSpc>
               <a:buNone/>
             </a:pPr>
             <a:r>
@@ -1492,9 +1504,94 @@
                 <a:ea typeface="Arial" pitchFamily="34" charset="-122"/>
                 <a:cs typeface="Arial" pitchFamily="34" charset="-120"/>
               </a:rPr>
-              <a:t>й віру зберегти в душі. :||</a:t>
+              <a:t>й віру зберегти в душі.</a:t>
             </a:r>
             <a:endParaRPr lang="en-US" sz="5200" dirty="0"/>
+          </a:p>
+        </p:txBody>
+      </p:sp>
+      <p:sp>
+        <p:nvSpPr>
+          <p:cNvPr id="3" name="Shape 1"/>
+          <p:cNvSpPr/>
+          <p:nvPr/>
+        </p:nvSpPr>
+        <p:spPr>
+          <a:xfrm>
+            <a:off x="1663471" y="3547872"/>
+            <a:ext cx="0" cy="1386840"/>
+          </a:xfrm>
+          <a:prstGeom prst="line">
+            <a:avLst/>
+          </a:prstGeom>
+          <a:noFill/>
+          <a:ln w="25400">
+            <a:solidFill>
+              <a:srgbClr val="8A8A8A"/>
+            </a:solidFill>
+            <a:prstDash val="solid"/>
+          </a:ln>
+        </p:spPr>
+      </p:sp>
+      <p:sp>
+        <p:nvSpPr>
+          <p:cNvPr id="4" name="Shape 2"/>
+          <p:cNvSpPr/>
+          <p:nvPr/>
+        </p:nvSpPr>
+        <p:spPr>
+          <a:xfrm>
+            <a:off x="10534625" y="3547872"/>
+            <a:ext cx="0" cy="1386840"/>
+          </a:xfrm>
+          <a:prstGeom prst="line">
+            <a:avLst/>
+          </a:prstGeom>
+          <a:noFill/>
+          <a:ln w="25400">
+            <a:solidFill>
+              <a:srgbClr val="8A8A8A"/>
+            </a:solidFill>
+            <a:prstDash val="solid"/>
+          </a:ln>
+        </p:spPr>
+      </p:sp>
+      <p:sp>
+        <p:nvSpPr>
+          <p:cNvPr id="5" name="Text 3"/>
+          <p:cNvSpPr txBox="1"/>
+          <p:nvPr/>
+        </p:nvSpPr>
+        <p:spPr>
+          <a:xfrm>
+            <a:off x="10633685" y="3921252"/>
+            <a:ext cx="1097280" cy="640080"/>
+          </a:xfrm>
+          <a:prstGeom prst="rect">
+            <a:avLst/>
+          </a:prstGeom>
+          <a:noFill/>
+          <a:ln/>
+        </p:spPr>
+        <p:txBody>
+          <a:bodyPr wrap="square" lIns="0" tIns="0" rIns="0" bIns="0" rtlCol="0" anchor="ctr"/>
+          <a:lstStyle/>
+          <a:p>
+            <a:pPr algn="l" indent="0" marL="0">
+              <a:buNone/>
+            </a:pPr>
+            <a:r>
+              <a:rPr lang="en-US" sz="3600" b="1" dirty="0">
+                <a:solidFill>
+                  <a:srgbClr val="BBBBBB"/>
+                </a:solidFill>
+                <a:latin typeface="Arial" pitchFamily="34" charset="0"/>
+                <a:ea typeface="Arial" pitchFamily="34" charset="-122"/>
+                <a:cs typeface="Arial" pitchFamily="34" charset="-120"/>
+              </a:rPr>
+              <a:t>×2</a:t>
+            </a:r>
+            <a:endParaRPr lang="en-US" sz="3600" dirty="0"/>
           </a:p>
         </p:txBody>
       </p:sp>
@@ -1552,6 +1649,9 @@
           <a:lstStyle/>
           <a:p>
             <a:pPr algn="ctr" indent="0" marL="0">
+              <a:lnSpc>
+                <a:spcPts val="6200"/>
+              </a:lnSpc>
               <a:buNone/>
             </a:pPr>
             <a:r>
@@ -1569,6 +1669,9 @@
           </a:p>
           <a:p>
             <a:pPr algn="ctr" indent="0" marL="0">
+              <a:lnSpc>
+                <a:spcPts val="6200"/>
+              </a:lnSpc>
               <a:buNone/>
             </a:pPr>
             <a:r>
@@ -1586,6 +1689,9 @@
           </a:p>
           <a:p>
             <a:pPr algn="ctr" indent="0" marL="0">
+              <a:lnSpc>
+                <a:spcPts val="6200"/>
+              </a:lnSpc>
               <a:buNone/>
             </a:pPr>
             <a:r>
@@ -1597,12 +1703,15 @@
                 <a:ea typeface="Arial" pitchFamily="34" charset="-122"/>
                 <a:cs typeface="Arial" pitchFamily="34" charset="-120"/>
               </a:rPr>
-              <a:t>||: Збережи від нарікання</a:t>
+              <a:t>Збережи від нарікання</a:t>
             </a:r>
             <a:endParaRPr lang="en-US" sz="5200" dirty="0"/>
           </a:p>
           <a:p>
             <a:pPr algn="ctr" indent="0" marL="0">
+              <a:lnSpc>
+                <a:spcPts val="6200"/>
+              </a:lnSpc>
               <a:buNone/>
             </a:pPr>
             <a:r>
@@ -1614,9 +1723,94 @@
                 <a:ea typeface="Arial" pitchFamily="34" charset="-122"/>
                 <a:cs typeface="Arial" pitchFamily="34" charset="-120"/>
               </a:rPr>
-              <a:t>в дні скорботні і сумні. :||</a:t>
+              <a:t>в дні скорботні і сумні.</a:t>
             </a:r>
             <a:endParaRPr lang="en-US" sz="5200" dirty="0"/>
+          </a:p>
+        </p:txBody>
+      </p:sp>
+      <p:sp>
+        <p:nvSpPr>
+          <p:cNvPr id="3" name="Shape 1"/>
+          <p:cNvSpPr/>
+          <p:nvPr/>
+        </p:nvSpPr>
+        <p:spPr>
+          <a:xfrm>
+            <a:off x="2099335" y="3547872"/>
+            <a:ext cx="0" cy="1386840"/>
+          </a:xfrm>
+          <a:prstGeom prst="line">
+            <a:avLst/>
+          </a:prstGeom>
+          <a:noFill/>
+          <a:ln w="25400">
+            <a:solidFill>
+              <a:srgbClr val="8A8A8A"/>
+            </a:solidFill>
+            <a:prstDash val="solid"/>
+          </a:ln>
+        </p:spPr>
+      </p:sp>
+      <p:sp>
+        <p:nvSpPr>
+          <p:cNvPr id="4" name="Shape 2"/>
+          <p:cNvSpPr/>
+          <p:nvPr/>
+        </p:nvSpPr>
+        <p:spPr>
+          <a:xfrm>
+            <a:off x="10098761" y="3547872"/>
+            <a:ext cx="0" cy="1386840"/>
+          </a:xfrm>
+          <a:prstGeom prst="line">
+            <a:avLst/>
+          </a:prstGeom>
+          <a:noFill/>
+          <a:ln w="25400">
+            <a:solidFill>
+              <a:srgbClr val="8A8A8A"/>
+            </a:solidFill>
+            <a:prstDash val="solid"/>
+          </a:ln>
+        </p:spPr>
+      </p:sp>
+      <p:sp>
+        <p:nvSpPr>
+          <p:cNvPr id="5" name="Text 3"/>
+          <p:cNvSpPr txBox="1"/>
+          <p:nvPr/>
+        </p:nvSpPr>
+        <p:spPr>
+          <a:xfrm>
+            <a:off x="10197821" y="3921252"/>
+            <a:ext cx="1097280" cy="640080"/>
+          </a:xfrm>
+          <a:prstGeom prst="rect">
+            <a:avLst/>
+          </a:prstGeom>
+          <a:noFill/>
+          <a:ln/>
+        </p:spPr>
+        <p:txBody>
+          <a:bodyPr wrap="square" lIns="0" tIns="0" rIns="0" bIns="0" rtlCol="0" anchor="ctr"/>
+          <a:lstStyle/>
+          <a:p>
+            <a:pPr algn="l" indent="0" marL="0">
+              <a:buNone/>
+            </a:pPr>
+            <a:r>
+              <a:rPr lang="en-US" sz="3600" b="1" dirty="0">
+                <a:solidFill>
+                  <a:srgbClr val="BBBBBB"/>
+                </a:solidFill>
+                <a:latin typeface="Arial" pitchFamily="34" charset="0"/>
+                <a:ea typeface="Arial" pitchFamily="34" charset="-122"/>
+                <a:cs typeface="Arial" pitchFamily="34" charset="-120"/>
+              </a:rPr>
+              <a:t>×2</a:t>
+            </a:r>
+            <a:endParaRPr lang="en-US" sz="3600" dirty="0"/>
           </a:p>
         </p:txBody>
       </p:sp>
@@ -1674,6 +1868,9 @@
           <a:lstStyle/>
           <a:p>
             <a:pPr algn="ctr" indent="0" marL="0">
+              <a:lnSpc>
+                <a:spcPts val="6200"/>
+              </a:lnSpc>
               <a:buNone/>
             </a:pPr>
             <a:r>
@@ -1691,6 +1888,9 @@
           </a:p>
           <a:p>
             <a:pPr algn="ctr" indent="0" marL="0">
+              <a:lnSpc>
+                <a:spcPts val="6200"/>
+              </a:lnSpc>
               <a:buNone/>
             </a:pPr>
             <a:r>
@@ -1708,6 +1908,9 @@
           </a:p>
           <a:p>
             <a:pPr algn="ctr" indent="0" marL="0">
+              <a:lnSpc>
+                <a:spcPts val="6200"/>
+              </a:lnSpc>
               <a:buNone/>
             </a:pPr>
             <a:r>
@@ -1719,12 +1922,15 @@
                 <a:ea typeface="Arial" pitchFamily="34" charset="-122"/>
                 <a:cs typeface="Arial" pitchFamily="34" charset="-120"/>
               </a:rPr>
-              <a:t>||: дай мені очима віри</a:t>
+              <a:t>дай мені очима віри</a:t>
             </a:r>
             <a:endParaRPr lang="en-US" sz="5200" dirty="0"/>
           </a:p>
           <a:p>
             <a:pPr algn="ctr" indent="0" marL="0">
+              <a:lnSpc>
+                <a:spcPts val="6200"/>
+              </a:lnSpc>
               <a:buNone/>
             </a:pPr>
             <a:r>
@@ -1736,9 +1942,94 @@
                 <a:ea typeface="Arial" pitchFamily="34" charset="-122"/>
                 <a:cs typeface="Arial" pitchFamily="34" charset="-120"/>
               </a:rPr>
-              <a:t>бачити Тебе завжди. :||</a:t>
+              <a:t>бачити Тебе завжди.</a:t>
             </a:r>
             <a:endParaRPr lang="en-US" sz="5200" dirty="0"/>
+          </a:p>
+        </p:txBody>
+      </p:sp>
+      <p:sp>
+        <p:nvSpPr>
+          <p:cNvPr id="3" name="Shape 1"/>
+          <p:cNvSpPr/>
+          <p:nvPr/>
+        </p:nvSpPr>
+        <p:spPr>
+          <a:xfrm>
+            <a:off x="2474443" y="3547872"/>
+            <a:ext cx="0" cy="1386840"/>
+          </a:xfrm>
+          <a:prstGeom prst="line">
+            <a:avLst/>
+          </a:prstGeom>
+          <a:noFill/>
+          <a:ln w="25400">
+            <a:solidFill>
+              <a:srgbClr val="8A8A8A"/>
+            </a:solidFill>
+            <a:prstDash val="solid"/>
+          </a:ln>
+        </p:spPr>
+      </p:sp>
+      <p:sp>
+        <p:nvSpPr>
+          <p:cNvPr id="4" name="Shape 2"/>
+          <p:cNvSpPr/>
+          <p:nvPr/>
+        </p:nvSpPr>
+        <p:spPr>
+          <a:xfrm>
+            <a:off x="9723653" y="3547872"/>
+            <a:ext cx="0" cy="1386840"/>
+          </a:xfrm>
+          <a:prstGeom prst="line">
+            <a:avLst/>
+          </a:prstGeom>
+          <a:noFill/>
+          <a:ln w="25400">
+            <a:solidFill>
+              <a:srgbClr val="8A8A8A"/>
+            </a:solidFill>
+            <a:prstDash val="solid"/>
+          </a:ln>
+        </p:spPr>
+      </p:sp>
+      <p:sp>
+        <p:nvSpPr>
+          <p:cNvPr id="5" name="Text 3"/>
+          <p:cNvSpPr txBox="1"/>
+          <p:nvPr/>
+        </p:nvSpPr>
+        <p:spPr>
+          <a:xfrm>
+            <a:off x="9822713" y="3921252"/>
+            <a:ext cx="1097280" cy="640080"/>
+          </a:xfrm>
+          <a:prstGeom prst="rect">
+            <a:avLst/>
+          </a:prstGeom>
+          <a:noFill/>
+          <a:ln/>
+        </p:spPr>
+        <p:txBody>
+          <a:bodyPr wrap="square" lIns="0" tIns="0" rIns="0" bIns="0" rtlCol="0" anchor="ctr"/>
+          <a:lstStyle/>
+          <a:p>
+            <a:pPr algn="l" indent="0" marL="0">
+              <a:buNone/>
+            </a:pPr>
+            <a:r>
+              <a:rPr lang="en-US" sz="3600" b="1" dirty="0">
+                <a:solidFill>
+                  <a:srgbClr val="BBBBBB"/>
+                </a:solidFill>
+                <a:latin typeface="Arial" pitchFamily="34" charset="0"/>
+                <a:ea typeface="Arial" pitchFamily="34" charset="-122"/>
+                <a:cs typeface="Arial" pitchFamily="34" charset="-120"/>
+              </a:rPr>
+              <a:t>×2</a:t>
+            </a:r>
+            <a:endParaRPr lang="en-US" sz="3600" dirty="0"/>
           </a:p>
         </p:txBody>
       </p:sp>
@@ -1796,6 +2087,9 @@
           <a:lstStyle/>
           <a:p>
             <a:pPr algn="ctr" indent="0" marL="0">
+              <a:lnSpc>
+                <a:spcPts val="6200"/>
+              </a:lnSpc>
               <a:buNone/>
             </a:pPr>
             <a:r>
@@ -1813,6 +2107,9 @@
           </a:p>
           <a:p>
             <a:pPr algn="ctr" indent="0" marL="0">
+              <a:lnSpc>
+                <a:spcPts val="6200"/>
+              </a:lnSpc>
               <a:buNone/>
             </a:pPr>
             <a:r>
@@ -1830,6 +2127,9 @@
           </a:p>
           <a:p>
             <a:pPr algn="ctr" indent="0" marL="0">
+              <a:lnSpc>
+                <a:spcPts val="6200"/>
+              </a:lnSpc>
               <a:buNone/>
             </a:pPr>
             <a:r>
@@ -1841,12 +2141,15 @@
                 <a:ea typeface="Arial" pitchFamily="34" charset="-122"/>
                 <a:cs typeface="Arial" pitchFamily="34" charset="-120"/>
               </a:rPr>
-              <a:t>||: і Твій голос ніжний чути,</a:t>
+              <a:t>і Твій голос ніжний чути,</a:t>
             </a:r>
             <a:endParaRPr lang="en-US" sz="5200" dirty="0"/>
           </a:p>
           <a:p>
             <a:pPr algn="ctr" indent="0" marL="0">
+              <a:lnSpc>
+                <a:spcPts val="6200"/>
+              </a:lnSpc>
               <a:buNone/>
             </a:pPr>
             <a:r>
@@ -1858,7 +2161,7 @@
                 <a:ea typeface="Arial" pitchFamily="34" charset="-122"/>
                 <a:cs typeface="Arial" pitchFamily="34" charset="-120"/>
               </a:rPr>
-              <a:t>по Твоїх слідах іти. :||</a:t>
+              <a:t>по Твоїх слідах іти.</a:t>
             </a:r>
             <a:endParaRPr lang="en-US" sz="5200" dirty="0"/>
           </a:p>
@@ -1866,7 +2169,92 @@
       </p:sp>
       <p:sp>
         <p:nvSpPr>
-          <p:cNvPr id="3" name="Text 1"/>
+          <p:cNvPr id="3" name="Shape 1"/>
+          <p:cNvSpPr/>
+          <p:nvPr/>
+        </p:nvSpPr>
+        <p:spPr>
+          <a:xfrm>
+            <a:off x="1811731" y="3547872"/>
+            <a:ext cx="0" cy="1386840"/>
+          </a:xfrm>
+          <a:prstGeom prst="line">
+            <a:avLst/>
+          </a:prstGeom>
+          <a:noFill/>
+          <a:ln w="25400">
+            <a:solidFill>
+              <a:srgbClr val="8A8A8A"/>
+            </a:solidFill>
+            <a:prstDash val="solid"/>
+          </a:ln>
+        </p:spPr>
+      </p:sp>
+      <p:sp>
+        <p:nvSpPr>
+          <p:cNvPr id="4" name="Shape 2"/>
+          <p:cNvSpPr/>
+          <p:nvPr/>
+        </p:nvSpPr>
+        <p:spPr>
+          <a:xfrm>
+            <a:off x="10386365" y="3547872"/>
+            <a:ext cx="0" cy="1386840"/>
+          </a:xfrm>
+          <a:prstGeom prst="line">
+            <a:avLst/>
+          </a:prstGeom>
+          <a:noFill/>
+          <a:ln w="25400">
+            <a:solidFill>
+              <a:srgbClr val="8A8A8A"/>
+            </a:solidFill>
+            <a:prstDash val="solid"/>
+          </a:ln>
+        </p:spPr>
+      </p:sp>
+      <p:sp>
+        <p:nvSpPr>
+          <p:cNvPr id="5" name="Text 3"/>
+          <p:cNvSpPr txBox="1"/>
+          <p:nvPr/>
+        </p:nvSpPr>
+        <p:spPr>
+          <a:xfrm>
+            <a:off x="10485425" y="3921252"/>
+            <a:ext cx="1097280" cy="640080"/>
+          </a:xfrm>
+          <a:prstGeom prst="rect">
+            <a:avLst/>
+          </a:prstGeom>
+          <a:noFill/>
+          <a:ln/>
+        </p:spPr>
+        <p:txBody>
+          <a:bodyPr wrap="square" lIns="0" tIns="0" rIns="0" bIns="0" rtlCol="0" anchor="ctr"/>
+          <a:lstStyle/>
+          <a:p>
+            <a:pPr algn="l" indent="0" marL="0">
+              <a:buNone/>
+            </a:pPr>
+            <a:r>
+              <a:rPr lang="en-US" sz="3600" b="1" dirty="0">
+                <a:solidFill>
+                  <a:srgbClr val="BBBBBB"/>
+                </a:solidFill>
+                <a:latin typeface="Arial" pitchFamily="34" charset="0"/>
+                <a:ea typeface="Arial" pitchFamily="34" charset="-122"/>
+                <a:cs typeface="Arial" pitchFamily="34" charset="-120"/>
+              </a:rPr>
+              <a:t>×2</a:t>
+            </a:r>
+            <a:endParaRPr lang="en-US" sz="3600" dirty="0"/>
+          </a:p>
+        </p:txBody>
+      </p:sp>
+      <p:sp>
+        <p:nvSpPr>
+          <p:cNvPr id="6" name="Text 4"/>
           <p:cNvSpPr txBox="1"/>
           <p:nvPr/>
         </p:nvSpPr>

</xml_diff>